<commit_message>
Technologies slide: rural territory wording, no lower block, plain statements
Co-Authored-By: Claude Sonnet 5.5 <noreply@anthropic.com>
Claude-Session: https://claude.ai/code/session_01PfagTkBBfn3ShTm5bX9M45
</commit_message>
<xml_diff>
--- a/slide_tehnologii_dlya_sela.pptx
+++ b/slide_tehnologii_dlya_sela.pptx
@@ -442,7 +442,7 @@
           <a:lstStyle/>
           <a:p>
             <a:r>
-              <a:t>К каждой технологии со слайда добавлена строка «В селе»: конкретное применение на сельской территории. Формулировки составлены при оформлении слайда как иллюстрации и не являются текстом Указа № 529; их стоит проверить на примерах конкретных районов.</a:t>
+              <a:t>К каждой технологии добавлена строка с конкретным применением на сельской территории. Формулировки составлены при оформлении слайда как иллюстрации к перечню Указа № 529; их стоит проверить на примерах конкретных районов.</a:t>
             </a:r>
           </a:p>
         </p:txBody>
@@ -5976,7 +5976,7 @@
                 </a:solidFill>
                 <a:latin typeface="Circe Bold" panose="020B0602020203020203" pitchFamily="34" charset="-52"/>
               </a:rPr>
-              <a:t>КРИТИЧЕСКИЕ И СКВОЗНЫЕ ТЕХНОЛОГИИ ДЛЯ СЕЛА</a:t>
+              <a:t>КРИТИЧЕСКИЕ И СКВОЗНЫЕ ТЕХНОЛОГИИ ДЛЯ СЕЛЬСКОЙ ТЕРРИТОРИИ</a:t>
             </a:r>
             <a:endParaRPr lang="en-US" sz="4000" dirty="0">
               <a:solidFill>
@@ -6040,7 +6040,7 @@
         </p:nvSpPr>
         <p:spPr>
           <a:xfrm>
-            <a:off x="1069330" y="1463040"/>
+            <a:off x="1069330" y="2011680"/>
             <a:ext cx="16871653" cy="457200"/>
           </a:xfrm>
           <a:prstGeom prst="rect">
@@ -6229,8 +6229,8 @@
         </p:nvSpPr>
         <p:spPr>
           <a:xfrm>
-            <a:off x="1069848" y="2103120"/>
-            <a:ext cx="4480560" cy="5440680"/>
+            <a:off x="1069330" y="2560320"/>
+            <a:ext cx="4012173" cy="6583680"/>
           </a:xfrm>
           <a:prstGeom prst="rect">
             <a:avLst/>
@@ -6288,7 +6288,7 @@
               </a:spcBef>
             </a:pPr>
             <a:r>
-              <a:rPr sz="1400" b="1" i="0">
+              <a:rPr sz="1500" b="1" i="0">
                 <a:solidFill>
                   <a:srgbClr val="062D3F"/>
                 </a:solidFill>
@@ -6297,11 +6297,11 @@
               <a:t>7   </a:t>
             </a:r>
             <a:r>
-              <a:rPr sz="1400" b="0" i="0">
-                <a:solidFill>
-                  <a:srgbClr val="222222"/>
-                </a:solidFill>
-                <a:latin typeface="Circe"/>
+              <a:rPr sz="1500" b="1" i="0">
+                <a:solidFill>
+                  <a:srgbClr val="062D3F"/>
+                </a:solidFill>
+                <a:latin typeface="Circe Bold"/>
               </a:rPr>
               <a:t>Повышение продуктивности сельхозживотных, в том числе селекцией</a:t>
             </a:r>
@@ -6313,22 +6313,13 @@
               </a:spcBef>
             </a:pPr>
             <a:r>
-              <a:rPr sz="1350" b="1" i="0">
+              <a:rPr sz="1450" b="0" i="0">
                 <a:solidFill>
                   <a:srgbClr val="062D3F"/>
                 </a:solidFill>
-                <a:latin typeface="Circe Bold"/>
-              </a:rPr>
-              <a:t>В селе: </a:t>
-            </a:r>
-            <a:r>
-              <a:rPr sz="1350" b="0" i="0">
-                <a:solidFill>
-                  <a:srgbClr val="062D3F"/>
-                </a:solidFill>
                 <a:latin typeface="Circe"/>
               </a:rPr>
-              <a:t>Больше молока и мяса при том же поголовье: выше доход хозяйств района</a:t>
+              <a:t>Рост удоев и привесов повышает доход хозяйств района</a:t>
             </a:r>
           </a:p>
           <a:p>
@@ -6338,7 +6329,7 @@
               </a:spcBef>
             </a:pPr>
             <a:r>
-              <a:rPr sz="1400" b="1" i="0">
+              <a:rPr sz="1500" b="1" i="0">
                 <a:solidFill>
                   <a:srgbClr val="062D3F"/>
                 </a:solidFill>
@@ -6347,11 +6338,11 @@
               <a:t>8   </a:t>
             </a:r>
             <a:r>
-              <a:rPr sz="1400" b="0" i="0">
-                <a:solidFill>
-                  <a:srgbClr val="222222"/>
-                </a:solidFill>
-                <a:latin typeface="Circe"/>
+              <a:rPr sz="1500" b="1" i="0">
+                <a:solidFill>
+                  <a:srgbClr val="062D3F"/>
+                </a:solidFill>
+                <a:latin typeface="Circe Bold"/>
               </a:rPr>
               <a:t>Ветеринарные препараты нового поколения</a:t>
             </a:r>
@@ -6363,22 +6354,13 @@
               </a:spcBef>
             </a:pPr>
             <a:r>
-              <a:rPr sz="1350" b="1" i="0">
+              <a:rPr sz="1450" b="0" i="0">
                 <a:solidFill>
                   <a:srgbClr val="062D3F"/>
                 </a:solidFill>
-                <a:latin typeface="Circe Bold"/>
-              </a:rPr>
-              <a:t>В селе: </a:t>
-            </a:r>
-            <a:r>
-              <a:rPr sz="1350" b="0" i="0">
-                <a:solidFill>
-                  <a:srgbClr val="062D3F"/>
-                </a:solidFill>
                 <a:latin typeface="Circe"/>
               </a:rPr>
-              <a:t>Защита стад от инфекций: меньше потерь у хозяйств и личных подворий</a:t>
+              <a:t>Вакцины и препараты защищают стада хозяйств и личных подворий</a:t>
             </a:r>
           </a:p>
           <a:p>
@@ -6388,7 +6370,7 @@
               </a:spcBef>
             </a:pPr>
             <a:r>
-              <a:rPr sz="1400" b="1" i="0">
+              <a:rPr sz="1500" b="1" i="0">
                 <a:solidFill>
                   <a:srgbClr val="062D3F"/>
                 </a:solidFill>
@@ -6397,11 +6379,11 @@
               <a:t>9   </a:t>
             </a:r>
             <a:r>
-              <a:rPr sz="1400" b="0" i="0">
-                <a:solidFill>
-                  <a:srgbClr val="222222"/>
-                </a:solidFill>
-                <a:latin typeface="Circe"/>
+              <a:rPr sz="1500" b="1" i="0">
+                <a:solidFill>
+                  <a:srgbClr val="062D3F"/>
+                </a:solidFill>
+                <a:latin typeface="Circe Bold"/>
               </a:rPr>
               <a:t>Новые сорта и гибриды, устойчивые к изменениям природной среды</a:t>
             </a:r>
@@ -6413,22 +6395,13 @@
               </a:spcBef>
             </a:pPr>
             <a:r>
-              <a:rPr sz="1350" b="1" i="0">
+              <a:rPr sz="1450" b="0" i="0">
                 <a:solidFill>
                   <a:srgbClr val="062D3F"/>
                 </a:solidFill>
-                <a:latin typeface="Circe Bold"/>
-              </a:rPr>
-              <a:t>В селе: </a:t>
-            </a:r>
-            <a:r>
-              <a:rPr sz="1350" b="0" i="0">
-                <a:solidFill>
-                  <a:srgbClr val="062D3F"/>
-                </a:solidFill>
                 <a:latin typeface="Circe"/>
               </a:rPr>
-              <a:t>Сохраняют урожай при засухах и заморозках, расширяют земледелие на север</a:t>
+              <a:t>Урожай сохраняется при засухах и заморозках, земледелие расширяется на север</a:t>
             </a:r>
           </a:p>
           <a:p>
@@ -6438,7 +6411,7 @@
               </a:spcBef>
             </a:pPr>
             <a:r>
-              <a:rPr sz="1400" b="1" i="0">
+              <a:rPr sz="1500" b="1" i="0">
                 <a:solidFill>
                   <a:srgbClr val="062D3F"/>
                 </a:solidFill>
@@ -6447,11 +6420,11 @@
               <a:t>10   </a:t>
             </a:r>
             <a:r>
-              <a:rPr sz="1400" b="0" i="0">
-                <a:solidFill>
-                  <a:srgbClr val="222222"/>
-                </a:solidFill>
-                <a:latin typeface="Circe"/>
+              <a:rPr sz="1500" b="1" i="0">
+                <a:solidFill>
+                  <a:srgbClr val="062D3F"/>
+                </a:solidFill>
+                <a:latin typeface="Circe Bold"/>
               </a:rPr>
               <a:t>Биологические и химические средства повышения урожайности и защиты растений</a:t>
             </a:r>
@@ -6463,22 +6436,13 @@
               </a:spcBef>
             </a:pPr>
             <a:r>
-              <a:rPr sz="1350" b="1" i="0">
+              <a:rPr sz="1450" b="0" i="0">
                 <a:solidFill>
                   <a:srgbClr val="062D3F"/>
                 </a:solidFill>
-                <a:latin typeface="Circe Bold"/>
-              </a:rPr>
-              <a:t>В селе: </a:t>
-            </a:r>
-            <a:r>
-              <a:rPr sz="1350" b="0" i="0">
-                <a:solidFill>
-                  <a:srgbClr val="062D3F"/>
-                </a:solidFill>
                 <a:latin typeface="Circe"/>
               </a:rPr>
-              <a:t>Возвращают плодородие и защищают посевы на бедных почвах Нечерноземья</a:t>
+              <a:t>Плодородие восстанавливается, посевы защищены на бедных почвах Нечерноземья</a:t>
             </a:r>
           </a:p>
         </p:txBody>
@@ -6491,8 +6455,8 @@
         </p:nvSpPr>
         <p:spPr>
           <a:xfrm>
-            <a:off x="5733288" y="2103120"/>
-            <a:ext cx="4160520" cy="5440680"/>
+            <a:off x="5355823" y="2560320"/>
+            <a:ext cx="4012173" cy="6583680"/>
           </a:xfrm>
           <a:prstGeom prst="rect">
             <a:avLst/>
@@ -6586,7 +6550,7 @@
               </a:spcBef>
             </a:pPr>
             <a:r>
-              <a:rPr sz="1400" b="1" i="0">
+              <a:rPr sz="1500" b="1" i="0">
                 <a:solidFill>
                   <a:srgbClr val="062D3F"/>
                 </a:solidFill>
@@ -6595,11 +6559,11 @@
               <a:t>14   </a:t>
             </a:r>
             <a:r>
-              <a:rPr sz="1400" b="0" i="0">
-                <a:solidFill>
-                  <a:srgbClr val="222222"/>
-                </a:solidFill>
-                <a:latin typeface="Circe"/>
+              <a:rPr sz="1500" b="1" i="0">
+                <a:solidFill>
+                  <a:srgbClr val="062D3F"/>
+                </a:solidFill>
+                <a:latin typeface="Circe Bold"/>
               </a:rPr>
               <a:t>Транспортные технологии, в том числе беспилотные и автономные системы</a:t>
             </a:r>
@@ -6611,22 +6575,13 @@
               </a:spcBef>
             </a:pPr>
             <a:r>
-              <a:rPr sz="1350" b="1" i="0">
+              <a:rPr sz="1450" b="0" i="0">
                 <a:solidFill>
                   <a:srgbClr val="062D3F"/>
                 </a:solidFill>
-                <a:latin typeface="Circe Bold"/>
-              </a:rPr>
-              <a:t>В селе: </a:t>
-            </a:r>
-            <a:r>
-              <a:rPr sz="1350" b="0" i="0">
-                <a:solidFill>
-                  <a:srgbClr val="062D3F"/>
-                </a:solidFill>
                 <a:latin typeface="Circe"/>
               </a:rPr>
-              <a:t>Дроны для обработки полей и доставка в посёлки без регулярного сообщения</a:t>
+              <a:t>Дроны обрабатывают поля и доставляют грузы в посёлки с редким транспортным сообщением</a:t>
             </a:r>
           </a:p>
           <a:p>
@@ -6636,7 +6591,7 @@
               </a:spcBef>
             </a:pPr>
             <a:r>
-              <a:rPr sz="1400" b="1" i="0">
+              <a:rPr sz="1500" b="1" i="0">
                 <a:solidFill>
                   <a:srgbClr val="062D3F"/>
                 </a:solidFill>
@@ -6645,11 +6600,11 @@
               <a:t>15   </a:t>
             </a:r>
             <a:r>
-              <a:rPr sz="1400" b="0" i="0">
-                <a:solidFill>
-                  <a:srgbClr val="222222"/>
-                </a:solidFill>
-                <a:latin typeface="Circe"/>
+              <a:rPr sz="1500" b="1" i="0">
+                <a:solidFill>
+                  <a:srgbClr val="062D3F"/>
+                </a:solidFill>
+                <a:latin typeface="Circe Bold"/>
               </a:rPr>
               <a:t>Космическое приборостроение для связи, навигации и дистанционного зондирования</a:t>
             </a:r>
@@ -6661,22 +6616,13 @@
               </a:spcBef>
             </a:pPr>
             <a:r>
-              <a:rPr sz="1350" b="1" i="0">
+              <a:rPr sz="1450" b="0" i="0">
                 <a:solidFill>
                   <a:srgbClr val="062D3F"/>
                 </a:solidFill>
-                <a:latin typeface="Circe Bold"/>
-              </a:rPr>
-              <a:t>В селе: </a:t>
-            </a:r>
-            <a:r>
-              <a:rPr sz="1350" b="0" i="0">
-                <a:solidFill>
-                  <a:srgbClr val="062D3F"/>
-                </a:solidFill>
                 <a:latin typeface="Circe"/>
               </a:rPr>
-              <a:t>Связь там, где нет вышек; снимки выявляют зарастающие поля и залежи</a:t>
+              <a:t>Спутниковая связь доступна в районах без вышек, снимки показывают зарастающие поля и залежи</a:t>
             </a:r>
           </a:p>
           <a:p>
@@ -6686,7 +6632,7 @@
               </a:spcBef>
             </a:pPr>
             <a:r>
-              <a:rPr sz="1400" b="1" i="0">
+              <a:rPr sz="1500" b="1" i="0">
                 <a:solidFill>
                   <a:srgbClr val="062D3F"/>
                 </a:solidFill>
@@ -6695,11 +6641,11 @@
               <a:t>25   </a:t>
             </a:r>
             <a:r>
-              <a:rPr sz="1400" b="0" i="1">
-                <a:solidFill>
-                  <a:srgbClr val="222222"/>
-                </a:solidFill>
-                <a:latin typeface="Circe"/>
+              <a:rPr sz="1500" b="1" i="1">
+                <a:solidFill>
+                  <a:srgbClr val="062D3F"/>
+                </a:solidFill>
+                <a:latin typeface="Circe Bold"/>
               </a:rPr>
               <a:t>Искусственный интеллект в отраслях экономики и управлении</a:t>
             </a:r>
@@ -6711,16 +6657,7 @@
               </a:spcBef>
             </a:pPr>
             <a:r>
-              <a:rPr sz="1350" b="1" i="0">
-                <a:solidFill>
-                  <a:srgbClr val="062D3F"/>
-                </a:solidFill>
-                <a:latin typeface="Circe Bold"/>
-              </a:rPr>
-              <a:t>В селе: </a:t>
-            </a:r>
-            <a:r>
-              <a:rPr sz="1350" b="0" i="0">
+              <a:rPr sz="1450" b="0" i="0">
                 <a:solidFill>
                   <a:srgbClr val="062D3F"/>
                 </a:solidFill>
@@ -6739,8 +6676,8 @@
         </p:nvSpPr>
         <p:spPr>
           <a:xfrm>
-            <a:off x="10076688" y="2103120"/>
-            <a:ext cx="3840480" cy="5440680"/>
+            <a:off x="9642316" y="2560320"/>
+            <a:ext cx="4012173" cy="6583680"/>
           </a:xfrm>
           <a:prstGeom prst="rect">
             <a:avLst/>
@@ -6798,7 +6735,7 @@
               </a:spcBef>
             </a:pPr>
             <a:r>
-              <a:rPr sz="1400" b="1" i="0">
+              <a:rPr sz="1500" b="1" i="0">
                 <a:solidFill>
                   <a:srgbClr val="062D3F"/>
                 </a:solidFill>
@@ -6807,11 +6744,11 @@
               <a:t>5   </a:t>
             </a:r>
             <a:r>
-              <a:rPr sz="1400" b="0" i="0">
-                <a:solidFill>
-                  <a:srgbClr val="222222"/>
-                </a:solidFill>
-                <a:latin typeface="Circe"/>
+              <a:rPr sz="1500" b="1" i="0">
+                <a:solidFill>
+                  <a:srgbClr val="062D3F"/>
+                </a:solidFill>
+                <a:latin typeface="Circe Bold"/>
               </a:rPr>
               <a:t>Технологии функционального и лечебного питания</a:t>
             </a:r>
@@ -6823,22 +6760,13 @@
               </a:spcBef>
             </a:pPr>
             <a:r>
-              <a:rPr sz="1350" b="1" i="0">
+              <a:rPr sz="1450" b="0" i="0">
                 <a:solidFill>
                   <a:srgbClr val="062D3F"/>
                 </a:solidFill>
-                <a:latin typeface="Circe Bold"/>
-              </a:rPr>
-              <a:t>В селе: </a:t>
-            </a:r>
-            <a:r>
-              <a:rPr sz="1350" b="0" i="0">
-                <a:solidFill>
-                  <a:srgbClr val="062D3F"/>
-                </a:solidFill>
                 <a:latin typeface="Circe"/>
               </a:rPr>
-              <a:t>Продукты с заданными свойствами из местного сырья: доход остаётся в районе</a:t>
+              <a:t>Из местного сырья производят продукты с заданными свойствами, доход остаётся в районе</a:t>
             </a:r>
           </a:p>
           <a:p>
@@ -6848,7 +6776,7 @@
               </a:spcBef>
             </a:pPr>
             <a:r>
-              <a:rPr sz="1400" b="1" i="0">
+              <a:rPr sz="1500" b="1" i="0">
                 <a:solidFill>
                   <a:srgbClr val="062D3F"/>
                 </a:solidFill>
@@ -6857,11 +6785,11 @@
               <a:t>22   </a:t>
             </a:r>
             <a:r>
-              <a:rPr sz="1400" b="0" i="1">
-                <a:solidFill>
-                  <a:srgbClr val="222222"/>
-                </a:solidFill>
-                <a:latin typeface="Circe"/>
+              <a:rPr sz="1500" b="1" i="1">
+                <a:solidFill>
+                  <a:srgbClr val="062D3F"/>
+                </a:solidFill>
+                <a:latin typeface="Circe Bold"/>
               </a:rPr>
               <a:t>Синтетическая биология и генная инженерия</a:t>
             </a:r>
@@ -6873,22 +6801,13 @@
               </a:spcBef>
             </a:pPr>
             <a:r>
-              <a:rPr sz="1350" b="1" i="0">
+              <a:rPr sz="1450" b="0" i="0">
                 <a:solidFill>
                   <a:srgbClr val="062D3F"/>
                 </a:solidFill>
-                <a:latin typeface="Circe Bold"/>
-              </a:rPr>
-              <a:t>В селе: </a:t>
-            </a:r>
-            <a:r>
-              <a:rPr sz="1350" b="0" i="0">
-                <a:solidFill>
-                  <a:srgbClr val="062D3F"/>
-                </a:solidFill>
                 <a:latin typeface="Circe"/>
               </a:rPr>
-              <a:t>Основа для отечественных сортов, пород и биопрепаратов, которые берут хозяйства</a:t>
+              <a:t>Основа для отечественных сортов, пород и биопрепаратов, которые применяют хозяйства</a:t>
             </a:r>
           </a:p>
           <a:p>
@@ -6898,7 +6817,7 @@
               </a:spcBef>
             </a:pPr>
             <a:r>
-              <a:rPr sz="1400" b="1" i="0">
+              <a:rPr sz="1500" b="1" i="0">
                 <a:solidFill>
                   <a:srgbClr val="062D3F"/>
                 </a:solidFill>
@@ -6907,11 +6826,11 @@
               <a:t>28   </a:t>
             </a:r>
             <a:r>
-              <a:rPr sz="1400" b="0" i="1">
-                <a:solidFill>
-                  <a:srgbClr val="222222"/>
-                </a:solidFill>
-                <a:latin typeface="Circe"/>
+              <a:rPr sz="1500" b="1" i="1">
+                <a:solidFill>
+                  <a:srgbClr val="062D3F"/>
+                </a:solidFill>
+                <a:latin typeface="Circe Bold"/>
               </a:rPr>
               <a:t>Биотехнологии в отраслях экономики</a:t>
             </a:r>
@@ -6923,22 +6842,13 @@
               </a:spcBef>
             </a:pPr>
             <a:r>
-              <a:rPr sz="1350" b="1" i="0">
+              <a:rPr sz="1450" b="0" i="0">
                 <a:solidFill>
                   <a:srgbClr val="062D3F"/>
                 </a:solidFill>
-                <a:latin typeface="Circe Bold"/>
-              </a:rPr>
-              <a:t>В селе: </a:t>
-            </a:r>
-            <a:r>
-              <a:rPr sz="1350" b="0" i="0">
-                <a:solidFill>
-                  <a:srgbClr val="062D3F"/>
-                </a:solidFill>
                 <a:latin typeface="Circe"/>
               </a:rPr>
-              <a:t>Переработка отходов АПК (навоз, барда, зерно) в корма, удобрения и биогаз</a:t>
+              <a:t>Отходы АПК (навоз, барда, зерно) перерабатываются в корма, удобрения и биогаз</a:t>
             </a:r>
           </a:p>
         </p:txBody>
@@ -6951,8 +6861,8 @@
         </p:nvSpPr>
         <p:spPr>
           <a:xfrm>
-            <a:off x="14100047" y="2103120"/>
-            <a:ext cx="3840480" cy="5440680"/>
+            <a:off x="13928809" y="2560320"/>
+            <a:ext cx="4012173" cy="6583680"/>
           </a:xfrm>
           <a:prstGeom prst="rect">
             <a:avLst/>
@@ -6986,7 +6896,7 @@
               </a:spcBef>
             </a:pPr>
             <a:r>
-              <a:rPr sz="1400" b="1" i="0">
+              <a:rPr sz="1500" b="1" i="0">
                 <a:solidFill>
                   <a:srgbClr val="062D3F"/>
                 </a:solidFill>
@@ -6995,11 +6905,11 @@
               <a:t>1   </a:t>
             </a:r>
             <a:r>
-              <a:rPr sz="1400" b="0" i="0">
-                <a:solidFill>
-                  <a:srgbClr val="222222"/>
-                </a:solidFill>
-                <a:latin typeface="Circe"/>
+              <a:rPr sz="1500" b="1" i="0">
+                <a:solidFill>
+                  <a:srgbClr val="062D3F"/>
+                </a:solidFill>
+                <a:latin typeface="Circe Bold"/>
               </a:rPr>
               <a:t>Генерация, распределение и хранение энергии</a:t>
             </a:r>
@@ -7011,22 +6921,13 @@
               </a:spcBef>
             </a:pPr>
             <a:r>
-              <a:rPr sz="1350" b="1" i="0">
+              <a:rPr sz="1450" b="0" i="0">
                 <a:solidFill>
                   <a:srgbClr val="062D3F"/>
                 </a:solidFill>
-                <a:latin typeface="Circe Bold"/>
-              </a:rPr>
-              <a:t>В селе: </a:t>
-            </a:r>
-            <a:r>
-              <a:rPr sz="1350" b="0" i="0">
-                <a:solidFill>
-                  <a:srgbClr val="062D3F"/>
-                </a:solidFill>
                 <a:latin typeface="Circe"/>
               </a:rPr>
-              <a:t>Местная генерация и накопители для удалённых посёлков и ферм</a:t>
+              <a:t>Местная генерация и накопители обеспечивают удалённые посёлки и фермы энергией</a:t>
             </a:r>
           </a:p>
           <a:p>
@@ -7036,7 +6937,7 @@
               </a:spcBef>
             </a:pPr>
             <a:r>
-              <a:rPr sz="1400" b="1" i="0">
+              <a:rPr sz="1500" b="1" i="0">
                 <a:solidFill>
                   <a:srgbClr val="062D3F"/>
                 </a:solidFill>
@@ -7045,11 +6946,11 @@
               <a:t>19   </a:t>
             </a:r>
             <a:r>
-              <a:rPr sz="1400" b="0" i="0">
-                <a:solidFill>
-                  <a:srgbClr val="222222"/>
-                </a:solidFill>
-                <a:latin typeface="Circe"/>
+              <a:rPr sz="1500" b="1" i="0">
+                <a:solidFill>
+                  <a:srgbClr val="062D3F"/>
+                </a:solidFill>
+                <a:latin typeface="Circe Bold"/>
               </a:rPr>
               <a:t>Мониторинг среды и климата, снижение рисков ЧС</a:t>
             </a:r>
@@ -7061,22 +6962,13 @@
               </a:spcBef>
             </a:pPr>
             <a:r>
-              <a:rPr sz="1350" b="1" i="0">
+              <a:rPr sz="1450" b="0" i="0">
                 <a:solidFill>
                   <a:srgbClr val="062D3F"/>
                 </a:solidFill>
-                <a:latin typeface="Circe Bold"/>
-              </a:rPr>
-              <a:t>В селе: </a:t>
-            </a:r>
-            <a:r>
-              <a:rPr sz="1350" b="0" i="0">
-                <a:solidFill>
-                  <a:srgbClr val="062D3F"/>
-                </a:solidFill>
                 <a:latin typeface="Circe"/>
               </a:rPr>
-              <a:t>Раннее оповещение о паводках, засухах и пожарах: защита земель и жителей</a:t>
+              <a:t>Раннее оповещение о паводках, засухах и пожарах защищает земли и жителей</a:t>
             </a:r>
           </a:p>
           <a:p>
@@ -7086,7 +6978,7 @@
               </a:spcBef>
             </a:pPr>
             <a:r>
-              <a:rPr sz="1400" b="1" i="0">
+              <a:rPr sz="1500" b="1" i="0">
                 <a:solidFill>
                   <a:srgbClr val="062D3F"/>
                 </a:solidFill>
@@ -7095,11 +6987,11 @@
               <a:t>21   </a:t>
             </a:r>
             <a:r>
-              <a:rPr sz="1400" b="0" i="0">
-                <a:solidFill>
-                  <a:srgbClr val="222222"/>
-                </a:solidFill>
-                <a:latin typeface="Circe"/>
+              <a:rPr sz="1500" b="1" i="0">
+                <a:solidFill>
+                  <a:srgbClr val="062D3F"/>
+                </a:solidFill>
+                <a:latin typeface="Circe Bold"/>
               </a:rPr>
               <a:t>Сохранение биоразнообразия, борьба с инвазивными видами</a:t>
             </a:r>
@@ -7111,22 +7003,13 @@
               </a:spcBef>
             </a:pPr>
             <a:r>
-              <a:rPr sz="1350" b="1" i="0">
+              <a:rPr sz="1450" b="0" i="0">
                 <a:solidFill>
                   <a:srgbClr val="062D3F"/>
                 </a:solidFill>
-                <a:latin typeface="Circe Bold"/>
-              </a:rPr>
-              <a:t>В селе: </a:t>
-            </a:r>
-            <a:r>
-              <a:rPr sz="1350" b="0" i="0">
-                <a:solidFill>
-                  <a:srgbClr val="062D3F"/>
-                </a:solidFill>
                 <a:latin typeface="Circe"/>
               </a:rPr>
-              <a:t>Борьба с борщевиком и другими инвазивными видами на заброшенных полях</a:t>
+              <a:t>Инвазивные виды, например борщевик, удаляются с заброшенных полей</a:t>
             </a:r>
           </a:p>
         </p:txBody>
@@ -7139,7 +7022,7 @@
         </p:nvSpPr>
         <p:spPr>
           <a:xfrm>
-            <a:off x="1069330" y="7635240"/>
+            <a:off x="1069330" y="9253728"/>
             <a:ext cx="16871653" cy="320040"/>
           </a:xfrm>
           <a:prstGeom prst="rect">
@@ -7162,582 +7045,11 @@
                 </a:solidFill>
                 <a:latin typeface="Circe"/>
               </a:rPr>
-              <a:t>Номера по перечню Указа № 529. Позиции 22–28 относятся к сквозным технологиям, остальные к критическим.</a:t>
+              <a:t>Номера по перечню Указа № 529. Позиции с 22 по 28 относятся к сквозным технологиям, остальные к критическим.</a:t>
             </a:r>
           </a:p>
         </p:txBody>
       </p:sp>
-      <p:sp>
-        <p:nvSpPr>
-          <p:cNvPr id="11" name="Rectangle 10"/>
-          <p:cNvSpPr/>
-          <p:nvPr/>
-        </p:nvSpPr>
-        <p:spPr>
-          <a:xfrm>
-            <a:off x="1069330" y="7955279"/>
-            <a:ext cx="16871653" cy="1600200"/>
-          </a:xfrm>
-          <a:prstGeom prst="rect">
-            <a:avLst/>
-          </a:prstGeom>
-          <a:solidFill>
-            <a:srgbClr val="062D3F"/>
-          </a:solidFill>
-          <a:ln>
-            <a:noFill/>
-          </a:ln>
-        </p:spPr>
-        <p:txBody>
-          <a:bodyPr wrap="square" lIns="320040" tIns="228600" rIns="320040" bIns="228600" rtlCol="0" anchor="t"/>
-          <a:lstStyle/>
-          <a:p>
-            <a:pPr algn="l"/>
-            <a:r>
-              <a:rPr sz="2100" b="1" dirty="0" err="1">
-                <a:solidFill>
-                  <a:srgbClr val="FFFFFF"/>
-                </a:solidFill>
-                <a:latin typeface="Circe Bold"/>
-              </a:rPr>
-              <a:t>Технология</a:t>
-            </a:r>
-            <a:r>
-              <a:rPr sz="2100" b="1" dirty="0">
-                <a:solidFill>
-                  <a:srgbClr val="FFFFFF"/>
-                </a:solidFill>
-                <a:latin typeface="Circe Bold"/>
-              </a:rPr>
-              <a:t> </a:t>
-            </a:r>
-            <a:r>
-              <a:rPr sz="2100" b="1" dirty="0" err="1">
-                <a:solidFill>
-                  <a:srgbClr val="FFFFFF"/>
-                </a:solidFill>
-                <a:latin typeface="Circe Bold"/>
-              </a:rPr>
-              <a:t>становится</a:t>
-            </a:r>
-            <a:r>
-              <a:rPr sz="2100" b="1" dirty="0">
-                <a:solidFill>
-                  <a:srgbClr val="FFFFFF"/>
-                </a:solidFill>
-                <a:latin typeface="Circe Bold"/>
-              </a:rPr>
-              <a:t> </a:t>
-            </a:r>
-            <a:r>
-              <a:rPr sz="2100" b="1" dirty="0" err="1">
-                <a:solidFill>
-                  <a:srgbClr val="FFFFFF"/>
-                </a:solidFill>
-                <a:latin typeface="Circe Bold"/>
-              </a:rPr>
-              <a:t>возможностью</a:t>
-            </a:r>
-            <a:r>
-              <a:rPr sz="2100" b="1" dirty="0">
-                <a:solidFill>
-                  <a:srgbClr val="FFFFFF"/>
-                </a:solidFill>
-                <a:latin typeface="Circe Bold"/>
-              </a:rPr>
-              <a:t> (O) </a:t>
-            </a:r>
-            <a:r>
-              <a:rPr sz="2100" b="1" dirty="0" err="1">
-                <a:solidFill>
-                  <a:srgbClr val="FFFFFF"/>
-                </a:solidFill>
-                <a:latin typeface="Circe Bold"/>
-              </a:rPr>
-              <a:t>для</a:t>
-            </a:r>
-            <a:r>
-              <a:rPr sz="2100" b="1" dirty="0">
-                <a:solidFill>
-                  <a:srgbClr val="FFFFFF"/>
-                </a:solidFill>
-                <a:latin typeface="Circe Bold"/>
-              </a:rPr>
-              <a:t> </a:t>
-            </a:r>
-            <a:r>
-              <a:rPr sz="2100" b="1" dirty="0" err="1">
-                <a:solidFill>
-                  <a:srgbClr val="FFFFFF"/>
-                </a:solidFill>
-                <a:latin typeface="Circe Bold"/>
-              </a:rPr>
-              <a:t>территории</a:t>
-            </a:r>
-            <a:r>
-              <a:rPr sz="2100" b="1" dirty="0">
-                <a:solidFill>
-                  <a:srgbClr val="FFFFFF"/>
-                </a:solidFill>
-                <a:latin typeface="Circe Bold"/>
-              </a:rPr>
-              <a:t>, </a:t>
-            </a:r>
-            <a:r>
-              <a:rPr sz="2100" b="1" dirty="0" err="1">
-                <a:solidFill>
-                  <a:srgbClr val="FFFFFF"/>
-                </a:solidFill>
-                <a:latin typeface="Circe Bold"/>
-              </a:rPr>
-              <a:t>если</a:t>
-            </a:r>
-            <a:r>
-              <a:rPr sz="2100" b="1" dirty="0">
-                <a:solidFill>
-                  <a:srgbClr val="FFFFFF"/>
-                </a:solidFill>
-                <a:latin typeface="Circe Bold"/>
-              </a:rPr>
-              <a:t> </a:t>
-            </a:r>
-            <a:r>
-              <a:rPr sz="2100" b="1" dirty="0" err="1">
-                <a:solidFill>
-                  <a:srgbClr val="FFFFFF"/>
-                </a:solidFill>
-                <a:latin typeface="Circe Bold"/>
-              </a:rPr>
-              <a:t>на</a:t>
-            </a:r>
-            <a:r>
-              <a:rPr sz="2100" b="1" dirty="0">
-                <a:solidFill>
-                  <a:srgbClr val="FFFFFF"/>
-                </a:solidFill>
-                <a:latin typeface="Circe Bold"/>
-              </a:rPr>
-              <a:t> </a:t>
-            </a:r>
-            <a:r>
-              <a:rPr sz="2100" b="1" dirty="0" err="1">
-                <a:solidFill>
-                  <a:srgbClr val="FFFFFF"/>
-                </a:solidFill>
-                <a:latin typeface="Circe Bold"/>
-              </a:rPr>
-              <a:t>ней</a:t>
-            </a:r>
-            <a:r>
-              <a:rPr sz="2100" b="1" dirty="0">
-                <a:solidFill>
-                  <a:srgbClr val="FFFFFF"/>
-                </a:solidFill>
-                <a:latin typeface="Circe Bold"/>
-              </a:rPr>
-              <a:t> </a:t>
-            </a:r>
-            <a:r>
-              <a:rPr sz="2100" b="1" dirty="0" err="1">
-                <a:solidFill>
-                  <a:srgbClr val="FFFFFF"/>
-                </a:solidFill>
-                <a:latin typeface="Circe Bold"/>
-              </a:rPr>
-              <a:t>есть</a:t>
-            </a:r>
-            <a:endParaRPr sz="2100" b="1" dirty="0">
-              <a:solidFill>
-                <a:srgbClr val="FFFFFF"/>
-              </a:solidFill>
-              <a:latin typeface="Circe Bold"/>
-            </a:endParaRPr>
-          </a:p>
-        </p:txBody>
-      </p:sp>
-      <p:sp>
-        <p:nvSpPr>
-          <p:cNvPr id="12" name="Rectangle 11"/>
-          <p:cNvSpPr/>
-          <p:nvPr/>
-        </p:nvSpPr>
-        <p:spPr>
-          <a:xfrm>
-            <a:off x="1389370" y="8686800"/>
-            <a:ext cx="3063434" cy="914400"/>
-          </a:xfrm>
-          <a:prstGeom prst="rect">
-            <a:avLst/>
-          </a:prstGeom>
-          <a:noFill/>
-          <a:ln>
-            <a:noFill/>
-          </a:ln>
-        </p:spPr>
-        <p:txBody>
-          <a:bodyPr wrap="square" lIns="0" tIns="0" rIns="0" bIns="0" rtlCol="0" anchor="t"/>
-          <a:lstStyle/>
-          <a:p>
-            <a:pPr algn="l"/>
-            <a:r>
-              <a:rPr sz="1700" b="0" dirty="0" err="1">
-                <a:solidFill>
-                  <a:srgbClr val="C9D8E0"/>
-                </a:solidFill>
-                <a:latin typeface="Circe"/>
-              </a:rPr>
-              <a:t>Кадры</a:t>
-            </a:r>
-            <a:r>
-              <a:rPr sz="1700" b="0" dirty="0">
-                <a:solidFill>
-                  <a:srgbClr val="C9D8E0"/>
-                </a:solidFill>
-                <a:latin typeface="Circe"/>
-              </a:rPr>
-              <a:t> и </a:t>
-            </a:r>
-            <a:r>
-              <a:rPr sz="1700" b="0" dirty="0" err="1">
-                <a:solidFill>
-                  <a:srgbClr val="C9D8E0"/>
-                </a:solidFill>
-                <a:latin typeface="Circe"/>
-              </a:rPr>
-              <a:t>компетенции</a:t>
-            </a:r>
-            <a:endParaRPr sz="1700" b="0" dirty="0">
-              <a:solidFill>
-                <a:srgbClr val="C9D8E0"/>
-              </a:solidFill>
-              <a:latin typeface="Circe"/>
-            </a:endParaRPr>
-          </a:p>
-        </p:txBody>
-      </p:sp>
-      <p:cxnSp>
-        <p:nvCxnSpPr>
-          <p:cNvPr id="13" name="Connector 12"/>
-          <p:cNvCxnSpPr/>
-          <p:nvPr/>
-        </p:nvCxnSpPr>
-        <p:spPr>
-          <a:xfrm>
-            <a:off x="1389370" y="8613648"/>
-            <a:ext cx="457200" cy="0"/>
-          </a:xfrm>
-          <a:prstGeom prst="line">
-            <a:avLst/>
-          </a:prstGeom>
-          <a:ln w="38100">
-            <a:solidFill>
-              <a:srgbClr val="FFCC00"/>
-            </a:solidFill>
-          </a:ln>
-        </p:spPr>
-        <p:style>
-          <a:lnRef idx="2">
-            <a:schemeClr val="accent1"/>
-          </a:lnRef>
-          <a:fillRef idx="0">
-            <a:schemeClr val="accent1"/>
-          </a:fillRef>
-          <a:effectRef idx="1">
-            <a:schemeClr val="accent1"/>
-          </a:effectRef>
-          <a:fontRef idx="minor">
-            <a:schemeClr val="tx1"/>
-          </a:fontRef>
-        </p:style>
-      </p:cxnSp>
-      <p:sp>
-        <p:nvSpPr>
-          <p:cNvPr id="14" name="Rectangle 13"/>
-          <p:cNvSpPr/>
-          <p:nvPr/>
-        </p:nvSpPr>
-        <p:spPr>
-          <a:xfrm>
-            <a:off x="4635684" y="8686800"/>
-            <a:ext cx="3063434" cy="914400"/>
-          </a:xfrm>
-          <a:prstGeom prst="rect">
-            <a:avLst/>
-          </a:prstGeom>
-          <a:noFill/>
-          <a:ln>
-            <a:noFill/>
-          </a:ln>
-        </p:spPr>
-        <p:txBody>
-          <a:bodyPr wrap="square" lIns="0" tIns="0" rIns="0" bIns="0" rtlCol="0" anchor="t"/>
-          <a:lstStyle/>
-          <a:p>
-            <a:pPr algn="l"/>
-            <a:r>
-              <a:rPr sz="1700" b="0">
-                <a:solidFill>
-                  <a:srgbClr val="C9D8E0"/>
-                </a:solidFill>
-                <a:latin typeface="Circe"/>
-              </a:rPr>
-              <a:t>Спрос со стороны хозяйств и переработчиков</a:t>
-            </a:r>
-          </a:p>
-        </p:txBody>
-      </p:sp>
-      <p:cxnSp>
-        <p:nvCxnSpPr>
-          <p:cNvPr id="15" name="Connector 14"/>
-          <p:cNvCxnSpPr/>
-          <p:nvPr/>
-        </p:nvCxnSpPr>
-        <p:spPr>
-          <a:xfrm>
-            <a:off x="4635684" y="8613648"/>
-            <a:ext cx="457200" cy="0"/>
-          </a:xfrm>
-          <a:prstGeom prst="line">
-            <a:avLst/>
-          </a:prstGeom>
-          <a:ln w="38100">
-            <a:solidFill>
-              <a:srgbClr val="FFCC00"/>
-            </a:solidFill>
-          </a:ln>
-        </p:spPr>
-        <p:style>
-          <a:lnRef idx="2">
-            <a:schemeClr val="accent1"/>
-          </a:lnRef>
-          <a:fillRef idx="0">
-            <a:schemeClr val="accent1"/>
-          </a:fillRef>
-          <a:effectRef idx="1">
-            <a:schemeClr val="accent1"/>
-          </a:effectRef>
-          <a:fontRef idx="minor">
-            <a:schemeClr val="tx1"/>
-          </a:fontRef>
-        </p:style>
-      </p:cxnSp>
-      <p:sp>
-        <p:nvSpPr>
-          <p:cNvPr id="16" name="Rectangle 15"/>
-          <p:cNvSpPr/>
-          <p:nvPr/>
-        </p:nvSpPr>
-        <p:spPr>
-          <a:xfrm>
-            <a:off x="7881998" y="8686800"/>
-            <a:ext cx="3063434" cy="914400"/>
-          </a:xfrm>
-          <a:prstGeom prst="rect">
-            <a:avLst/>
-          </a:prstGeom>
-          <a:noFill/>
-          <a:ln>
-            <a:noFill/>
-          </a:ln>
-        </p:spPr>
-        <p:txBody>
-          <a:bodyPr wrap="square" lIns="0" tIns="0" rIns="0" bIns="0" rtlCol="0" anchor="t"/>
-          <a:lstStyle/>
-          <a:p>
-            <a:pPr algn="l"/>
-            <a:r>
-              <a:rPr sz="1700" b="0">
-                <a:solidFill>
-                  <a:srgbClr val="C9D8E0"/>
-                </a:solidFill>
-                <a:latin typeface="Circe"/>
-              </a:rPr>
-              <a:t>Связь и цифровая инфраструктура</a:t>
-            </a:r>
-          </a:p>
-        </p:txBody>
-      </p:sp>
-      <p:cxnSp>
-        <p:nvCxnSpPr>
-          <p:cNvPr id="17" name="Connector 16"/>
-          <p:cNvCxnSpPr>
-            <a:cxnSpLocks/>
-          </p:cNvCxnSpPr>
-          <p:nvPr/>
-        </p:nvCxnSpPr>
-        <p:spPr>
-          <a:xfrm>
-            <a:off x="7881998" y="8613648"/>
-            <a:ext cx="457200" cy="0"/>
-          </a:xfrm>
-          <a:prstGeom prst="line">
-            <a:avLst/>
-          </a:prstGeom>
-          <a:ln w="38100">
-            <a:solidFill>
-              <a:srgbClr val="FFCC00"/>
-            </a:solidFill>
-          </a:ln>
-        </p:spPr>
-        <p:style>
-          <a:lnRef idx="2">
-            <a:schemeClr val="accent1"/>
-          </a:lnRef>
-          <a:fillRef idx="0">
-            <a:schemeClr val="accent1"/>
-          </a:fillRef>
-          <a:effectRef idx="1">
-            <a:schemeClr val="accent1"/>
-          </a:effectRef>
-          <a:fontRef idx="minor">
-            <a:schemeClr val="tx1"/>
-          </a:fontRef>
-        </p:style>
-      </p:cxnSp>
-      <p:sp>
-        <p:nvSpPr>
-          <p:cNvPr id="18" name="Rectangle 17"/>
-          <p:cNvSpPr/>
-          <p:nvPr/>
-        </p:nvSpPr>
-        <p:spPr>
-          <a:xfrm>
-            <a:off x="11128312" y="8686800"/>
-            <a:ext cx="3063434" cy="914400"/>
-          </a:xfrm>
-          <a:prstGeom prst="rect">
-            <a:avLst/>
-          </a:prstGeom>
-          <a:noFill/>
-          <a:ln>
-            <a:noFill/>
-          </a:ln>
-        </p:spPr>
-        <p:txBody>
-          <a:bodyPr wrap="square" lIns="0" tIns="0" rIns="0" bIns="0" rtlCol="0" anchor="t"/>
-          <a:lstStyle/>
-          <a:p>
-            <a:pPr algn="l"/>
-            <a:r>
-              <a:rPr sz="1700" b="0">
-                <a:solidFill>
-                  <a:srgbClr val="C9D8E0"/>
-                </a:solidFill>
-                <a:latin typeface="Circe"/>
-              </a:rPr>
-              <a:t>Научный партнёр рядом (вуз, НИИ, опытная станция)</a:t>
-            </a:r>
-          </a:p>
-        </p:txBody>
-      </p:sp>
-      <p:cxnSp>
-        <p:nvCxnSpPr>
-          <p:cNvPr id="19" name="Connector 18"/>
-          <p:cNvCxnSpPr>
-            <a:cxnSpLocks/>
-          </p:cNvCxnSpPr>
-          <p:nvPr/>
-        </p:nvCxnSpPr>
-        <p:spPr>
-          <a:xfrm>
-            <a:off x="11128312" y="8613648"/>
-            <a:ext cx="457200" cy="0"/>
-          </a:xfrm>
-          <a:prstGeom prst="line">
-            <a:avLst/>
-          </a:prstGeom>
-          <a:ln w="38100">
-            <a:solidFill>
-              <a:srgbClr val="FFCC00"/>
-            </a:solidFill>
-          </a:ln>
-        </p:spPr>
-        <p:style>
-          <a:lnRef idx="2">
-            <a:schemeClr val="accent1"/>
-          </a:lnRef>
-          <a:fillRef idx="0">
-            <a:schemeClr val="accent1"/>
-          </a:fillRef>
-          <a:effectRef idx="1">
-            <a:schemeClr val="accent1"/>
-          </a:effectRef>
-          <a:fontRef idx="minor">
-            <a:schemeClr val="tx1"/>
-          </a:fontRef>
-        </p:style>
-      </p:cxnSp>
-      <p:sp>
-        <p:nvSpPr>
-          <p:cNvPr id="20" name="Rectangle 19"/>
-          <p:cNvSpPr/>
-          <p:nvPr/>
-        </p:nvSpPr>
-        <p:spPr>
-          <a:xfrm>
-            <a:off x="14374626" y="8686800"/>
-            <a:ext cx="3063434" cy="914400"/>
-          </a:xfrm>
-          <a:prstGeom prst="rect">
-            <a:avLst/>
-          </a:prstGeom>
-          <a:noFill/>
-          <a:ln>
-            <a:noFill/>
-          </a:ln>
-        </p:spPr>
-        <p:txBody>
-          <a:bodyPr wrap="square" lIns="0" tIns="0" rIns="0" bIns="0" rtlCol="0" anchor="t"/>
-          <a:lstStyle/>
-          <a:p>
-            <a:pPr algn="l"/>
-            <a:r>
-              <a:rPr sz="1700" b="0">
-                <a:solidFill>
-                  <a:srgbClr val="C9D8E0"/>
-                </a:solidFill>
-                <a:latin typeface="Circe"/>
-              </a:rPr>
-              <a:t>Финансирование и меры поддержки</a:t>
-            </a:r>
-          </a:p>
-        </p:txBody>
-      </p:sp>
-      <p:cxnSp>
-        <p:nvCxnSpPr>
-          <p:cNvPr id="21" name="Connector 20"/>
-          <p:cNvCxnSpPr/>
-          <p:nvPr/>
-        </p:nvCxnSpPr>
-        <p:spPr>
-          <a:xfrm>
-            <a:off x="14374626" y="8613648"/>
-            <a:ext cx="457200" cy="0"/>
-          </a:xfrm>
-          <a:prstGeom prst="line">
-            <a:avLst/>
-          </a:prstGeom>
-          <a:ln w="38100">
-            <a:solidFill>
-              <a:srgbClr val="FFCC00"/>
-            </a:solidFill>
-          </a:ln>
-        </p:spPr>
-        <p:style>
-          <a:lnRef idx="2">
-            <a:schemeClr val="accent1"/>
-          </a:lnRef>
-          <a:fillRef idx="0">
-            <a:schemeClr val="accent1"/>
-          </a:fillRef>
-          <a:effectRef idx="1">
-            <a:schemeClr val="accent1"/>
-          </a:effectRef>
-          <a:fontRef idx="minor">
-            <a:schemeClr val="tx1"/>
-          </a:fontRef>
-        </p:style>
-      </p:cxnSp>
     </p:spTree>
   </p:cSld>
   <p:clrMapOvr>

</xml_diff>